<commit_message>
IITPSA slide: link students to the Institute's Constitution (iitpsa.org.za/constitution) in lesson and PPT; lesson text now auto-links bare URLs
Co-authored-by: Copilot <223556219+Copilot@users.noreply.github.com>
</commit_message>
<xml_diff>
--- a/public/downloads/US-114055-Ethics-Professionalism.pptx
+++ b/public/downloads/US-114055-Ethics-Professionalism.pptx
@@ -18267,7 +18267,67 @@
         </p:nvSpPr>
         <p:spPr>
           <a:xfrm>
-            <a:off x="502920" y="2487168"/>
+            <a:off x="502920" y="2395728"/>
+            <a:ext cx="11183112" cy="292608"/>
+          </a:xfrm>
+          <a:prstGeom prst="rect">
+            <a:avLst/>
+          </a:prstGeom>
+          <a:noFill/>
+          <a:ln/>
+        </p:spPr>
+        <p:txBody>
+          <a:bodyPr wrap="square" rtlCol="0" anchor="ctr"/>
+          <a:lstStyle/>
+          <a:p>
+            <a:pPr indent="0" marL="0">
+              <a:buNone/>
+            </a:pPr>
+            <a:r>
+              <a:rPr lang="en-US" sz="1350" dirty="0">
+                <a:solidFill>
+                  <a:srgbClr val="002050"/>
+                </a:solidFill>
+                <a:latin typeface="Aptos" pitchFamily="34" charset="0"/>
+                <a:ea typeface="Aptos" pitchFamily="34" charset="-122"/>
+                <a:cs typeface="Aptos" pitchFamily="34" charset="-120"/>
+              </a:rPr>
+              <a:t>Read the Institute's current Constitution: </a:t>
+            </a:r>
+            <a:pPr indent="0" marL="0">
+              <a:buNone/>
+            </a:pPr>
+            <a:r>
+              <a:rPr lang="en-US" sz="1350" b="1" u="sng" dirty="0">
+                <a:solidFill>
+                  <a:srgbClr val="0F6CBD"/>
+                </a:solidFill>
+                <a:latin typeface="Aptos" pitchFamily="34" charset="0"/>
+                <a:ea typeface="Aptos" pitchFamily="34" charset="-122"/>
+                <a:cs typeface="Aptos" pitchFamily="34" charset="-120"/>
+                <a:hlinkClick r:id="rId1" invalidUrl="" action="" tgtFrame="" tooltip="IITPSA Constitution" history="1" highlightClick="0" endSnd="0">
+                  <a:extLst>
+                    <a:ext uri="{A12FA001-AC4F-418D-AE19-62706E023703}">
+                      <ahyp:hlinkClr xmlns:ahyp="http://schemas.microsoft.com/office/drawing/2018/hyperlinkcolor" val="tx"/>
+                    </a:ext>
+                  </a:extLst>
+                </a:hlinkClick>
+              </a:rPr>
+              <a:t>www.iitpsa.org.za/constitution</a:t>
+            </a:r>
+            <a:endParaRPr lang="en-US" sz="1350" dirty="0"/>
+          </a:p>
+        </p:txBody>
+      </p:sp>
+      <p:sp>
+        <p:nvSpPr>
+          <p:cNvPr id="9" name="Text 7"/>
+          <p:cNvSpPr/>
+          <p:nvPr/>
+        </p:nvSpPr>
+        <p:spPr>
+          <a:xfrm>
+            <a:off x="502920" y="2743200"/>
             <a:ext cx="11183112" cy="274320"/>
           </a:xfrm>
           <a:prstGeom prst="rect">
@@ -18300,13 +18360,13 @@
       </p:sp>
       <p:sp>
         <p:nvSpPr>
-          <p:cNvPr id="9" name="Shape 7"/>
-          <p:cNvSpPr/>
-          <p:nvPr/>
-        </p:nvSpPr>
-        <p:spPr>
-          <a:xfrm>
-            <a:off x="502920" y="2788920"/>
+          <p:cNvPr id="10" name="Shape 8"/>
+          <p:cNvSpPr/>
+          <p:nvPr/>
+        </p:nvSpPr>
+        <p:spPr>
+          <a:xfrm>
+            <a:off x="502920" y="3035808"/>
             <a:ext cx="457200" cy="457200"/>
           </a:xfrm>
           <a:prstGeom prst="ellipse">
@@ -18320,13 +18380,13 @@
       </p:sp>
       <p:sp>
         <p:nvSpPr>
-          <p:cNvPr id="10" name="Text 8"/>
-          <p:cNvSpPr/>
-          <p:nvPr/>
-        </p:nvSpPr>
-        <p:spPr>
-          <a:xfrm>
-            <a:off x="502920" y="2788920"/>
+          <p:cNvPr id="11" name="Text 9"/>
+          <p:cNvSpPr/>
+          <p:nvPr/>
+        </p:nvSpPr>
+        <p:spPr>
+          <a:xfrm>
+            <a:off x="502920" y="3035808"/>
             <a:ext cx="457200" cy="457200"/>
           </a:xfrm>
           <a:prstGeom prst="rect">
@@ -18359,14 +18419,14 @@
       </p:sp>
       <p:sp>
         <p:nvSpPr>
-          <p:cNvPr id="11" name="Text 9"/>
-          <p:cNvSpPr/>
-          <p:nvPr/>
-        </p:nvSpPr>
-        <p:spPr>
-          <a:xfrm>
-            <a:off x="1161288" y="2743200"/>
-            <a:ext cx="10360152" cy="374904"/>
+          <p:cNvPr id="12" name="Text 10"/>
+          <p:cNvSpPr/>
+          <p:nvPr/>
+        </p:nvSpPr>
+        <p:spPr>
+          <a:xfrm>
+            <a:off x="1161288" y="2990088"/>
+            <a:ext cx="10360152" cy="338328"/>
           </a:xfrm>
           <a:prstGeom prst="rect">
             <a:avLst/>
@@ -18401,13 +18461,13 @@
       </p:sp>
       <p:sp>
         <p:nvSpPr>
-          <p:cNvPr id="12" name="Shape 10"/>
-          <p:cNvSpPr/>
-          <p:nvPr/>
-        </p:nvSpPr>
-        <p:spPr>
-          <a:xfrm>
-            <a:off x="502920" y="3300984"/>
+          <p:cNvPr id="13" name="Shape 11"/>
+          <p:cNvSpPr/>
+          <p:nvPr/>
+        </p:nvSpPr>
+        <p:spPr>
+          <a:xfrm>
+            <a:off x="502920" y="3511296"/>
             <a:ext cx="457200" cy="457200"/>
           </a:xfrm>
           <a:prstGeom prst="ellipse">
@@ -18421,13 +18481,13 @@
       </p:sp>
       <p:sp>
         <p:nvSpPr>
-          <p:cNvPr id="13" name="Text 11"/>
-          <p:cNvSpPr/>
-          <p:nvPr/>
-        </p:nvSpPr>
-        <p:spPr>
-          <a:xfrm>
-            <a:off x="502920" y="3300984"/>
+          <p:cNvPr id="14" name="Text 12"/>
+          <p:cNvSpPr/>
+          <p:nvPr/>
+        </p:nvSpPr>
+        <p:spPr>
+          <a:xfrm>
+            <a:off x="502920" y="3511296"/>
             <a:ext cx="457200" cy="457200"/>
           </a:xfrm>
           <a:prstGeom prst="rect">
@@ -18460,14 +18520,14 @@
       </p:sp>
       <p:sp>
         <p:nvSpPr>
-          <p:cNvPr id="14" name="Text 12"/>
-          <p:cNvSpPr/>
-          <p:nvPr/>
-        </p:nvSpPr>
-        <p:spPr>
-          <a:xfrm>
-            <a:off x="1161288" y="3255264"/>
-            <a:ext cx="10360152" cy="374904"/>
+          <p:cNvPr id="15" name="Text 13"/>
+          <p:cNvSpPr/>
+          <p:nvPr/>
+        </p:nvSpPr>
+        <p:spPr>
+          <a:xfrm>
+            <a:off x="1161288" y="3465576"/>
+            <a:ext cx="10360152" cy="338328"/>
           </a:xfrm>
           <a:prstGeom prst="rect">
             <a:avLst/>
@@ -18502,13 +18562,13 @@
       </p:sp>
       <p:sp>
         <p:nvSpPr>
-          <p:cNvPr id="15" name="Shape 13"/>
-          <p:cNvSpPr/>
-          <p:nvPr/>
-        </p:nvSpPr>
-        <p:spPr>
-          <a:xfrm>
-            <a:off x="502920" y="3813048"/>
+          <p:cNvPr id="16" name="Shape 14"/>
+          <p:cNvSpPr/>
+          <p:nvPr/>
+        </p:nvSpPr>
+        <p:spPr>
+          <a:xfrm>
+            <a:off x="502920" y="3986784"/>
             <a:ext cx="457200" cy="457200"/>
           </a:xfrm>
           <a:prstGeom prst="ellipse">
@@ -18522,13 +18582,13 @@
       </p:sp>
       <p:sp>
         <p:nvSpPr>
-          <p:cNvPr id="16" name="Text 14"/>
-          <p:cNvSpPr/>
-          <p:nvPr/>
-        </p:nvSpPr>
-        <p:spPr>
-          <a:xfrm>
-            <a:off x="502920" y="3813048"/>
+          <p:cNvPr id="17" name="Text 15"/>
+          <p:cNvSpPr/>
+          <p:nvPr/>
+        </p:nvSpPr>
+        <p:spPr>
+          <a:xfrm>
+            <a:off x="502920" y="3986784"/>
             <a:ext cx="457200" cy="457200"/>
           </a:xfrm>
           <a:prstGeom prst="rect">
@@ -18561,14 +18621,14 @@
       </p:sp>
       <p:sp>
         <p:nvSpPr>
-          <p:cNvPr id="17" name="Text 15"/>
-          <p:cNvSpPr/>
-          <p:nvPr/>
-        </p:nvSpPr>
-        <p:spPr>
-          <a:xfrm>
-            <a:off x="1161288" y="3767328"/>
-            <a:ext cx="10360152" cy="374904"/>
+          <p:cNvPr id="18" name="Text 16"/>
+          <p:cNvSpPr/>
+          <p:nvPr/>
+        </p:nvSpPr>
+        <p:spPr>
+          <a:xfrm>
+            <a:off x="1161288" y="3941064"/>
+            <a:ext cx="10360152" cy="338328"/>
           </a:xfrm>
           <a:prstGeom prst="rect">
             <a:avLst/>
@@ -18603,13 +18663,13 @@
       </p:sp>
       <p:sp>
         <p:nvSpPr>
-          <p:cNvPr id="18" name="Shape 16"/>
-          <p:cNvSpPr/>
-          <p:nvPr/>
-        </p:nvSpPr>
-        <p:spPr>
-          <a:xfrm>
-            <a:off x="502920" y="4325112"/>
+          <p:cNvPr id="19" name="Shape 17"/>
+          <p:cNvSpPr/>
+          <p:nvPr/>
+        </p:nvSpPr>
+        <p:spPr>
+          <a:xfrm>
+            <a:off x="502920" y="4462272"/>
             <a:ext cx="457200" cy="457200"/>
           </a:xfrm>
           <a:prstGeom prst="ellipse">
@@ -18623,13 +18683,13 @@
       </p:sp>
       <p:sp>
         <p:nvSpPr>
-          <p:cNvPr id="19" name="Text 17"/>
-          <p:cNvSpPr/>
-          <p:nvPr/>
-        </p:nvSpPr>
-        <p:spPr>
-          <a:xfrm>
-            <a:off x="502920" y="4325112"/>
+          <p:cNvPr id="20" name="Text 18"/>
+          <p:cNvSpPr/>
+          <p:nvPr/>
+        </p:nvSpPr>
+        <p:spPr>
+          <a:xfrm>
+            <a:off x="502920" y="4462272"/>
             <a:ext cx="457200" cy="457200"/>
           </a:xfrm>
           <a:prstGeom prst="rect">
@@ -18662,14 +18722,14 @@
       </p:sp>
       <p:sp>
         <p:nvSpPr>
-          <p:cNvPr id="20" name="Text 18"/>
-          <p:cNvSpPr/>
-          <p:nvPr/>
-        </p:nvSpPr>
-        <p:spPr>
-          <a:xfrm>
-            <a:off x="1161288" y="4279392"/>
-            <a:ext cx="10360152" cy="374904"/>
+          <p:cNvPr id="21" name="Text 19"/>
+          <p:cNvSpPr/>
+          <p:nvPr/>
+        </p:nvSpPr>
+        <p:spPr>
+          <a:xfrm>
+            <a:off x="1161288" y="4416552"/>
+            <a:ext cx="10360152" cy="338328"/>
           </a:xfrm>
           <a:prstGeom prst="rect">
             <a:avLst/>
@@ -18704,7 +18764,7 @@
       </p:sp>
       <p:sp>
         <p:nvSpPr>
-          <p:cNvPr id="21" name="Shape 19"/>
+          <p:cNvPr id="22" name="Shape 20"/>
           <p:cNvSpPr/>
           <p:nvPr/>
         </p:nvSpPr>
@@ -18738,17 +18798,17 @@
       </p:sp>
       <p:pic>
         <p:nvPicPr>
-          <p:cNvPr id="22" name="Image 0" descr="preencoded.png">    </p:cNvPr>
+          <p:cNvPr id="23" name="Image 0" descr="preencoded.png">    </p:cNvPr>
           <p:cNvPicPr>
             <a:picLocks noChangeAspect="1"/>
           </p:cNvPicPr>
           <p:nvPr/>
         </p:nvPicPr>
         <p:blipFill>
-          <a:blip r:embed="rId1">
+          <a:blip r:embed="rId2">
             <a:extLst>
               <a:ext uri="{96DAC541-7B7A-43D3-8B79-37D633B846F1}">
-                <asvg:svgBlip xmlns:asvg="http://schemas.microsoft.com/office/drawing/2016/SVG/main" r:embed="rId2"/>
+                <asvg:svgBlip xmlns:asvg="http://schemas.microsoft.com/office/drawing/2016/SVG/main" r:embed="rId3"/>
               </a:ext>
             </a:extLst>
           </a:blip>
@@ -18768,7 +18828,7 @@
       </p:pic>
       <p:sp>
         <p:nvSpPr>
-          <p:cNvPr id="23" name="Text 20"/>
+          <p:cNvPr id="24" name="Text 21"/>
           <p:cNvSpPr/>
           <p:nvPr/>
         </p:nvSpPr>

</xml_diff>